<commit_message>
docs(presentation): refresh test counts after merging main
</commit_message>
<xml_diff>
--- a/docs/presentation/ClaimsWatch.pptx
+++ b/docs/presentation/ClaimsWatch.pptx
@@ -11544,7 +11544,7 @@
                 </a:solidFill>
                 <a:latin typeface="JetBrains Mono"/>
               </a:rPr>
-              <a:t>146</a:t>
+              <a:t>150</a:t>
             </a:r>
             <a:r>
               <a:rPr sz="1400" b="0" i="0">
@@ -11562,7 +11562,7 @@
                 </a:solidFill>
                 <a:latin typeface="JetBrains Mono"/>
               </a:rPr>
-              <a:t>80</a:t>
+              <a:t>87</a:t>
             </a:r>
             <a:r>
               <a:rPr sz="1400" b="0" i="0">

</xml_diff>